<commit_message>
Added GUI that shows translation progress.
</commit_message>
<xml_diff>
--- a/results/Paraphrasing and Citing V2 Spanish.pptx
+++ b/results/Paraphrasing and Citing V2 Spanish.pptx
@@ -13056,7 +13056,8 @@
           <a:lstStyle/>
           <a:p>
             <a:r>
-              <a:t>Obras citadas</a:t>
+              <a:rPr lang="en-US" dirty="0"/>
+              <a:t>Works Cited</a:t>
             </a:r>
           </a:p>
         </p:txBody>
@@ -13085,33 +13086,90 @@
           <a:lstStyle/>
           <a:p>
             <a:r>
-              <a:t>[1] https://www.plagiarism.org/article/what-is-citation</a:t>
-            </a:r>
-          </a:p>
-          <a:p>
-            <a:r>
-              <a:t>[2] https://www.usm.edu/speaking-center/citingsourcesinaspeech.pdf</a:t>
-            </a:r>
-          </a:p>
-          <a:p>
-            <a:r>
-              <a:t>[3] https://www.cbsnews.com/newyork/news/autism-spectrum-works-nonprofit-pop-up-stores-american-dream/</a:t>
-            </a:r>
-          </a:p>
-          <a:p>
-            <a:r>
-              <a:t>[4] https://lo.unisa.edu.au/mod/book/view.php?id=252144</a:t>
-            </a:r>
-          </a:p>
-          <a:p>
-            <a:r>
-              <a:t>[5] https://www.monash.edu/learnhq/write-like-a-pro/acknowledge-sources/paraphrase-summarise-and-quote-well/paraphrase</a:t>
-            </a:r>
-          </a:p>
-          <a:p>
-            <a:r>
-              <a:t>[6] https://apastyle.apa.org/style-grammar-guidelines/citations/quotations</a:t>
-            </a:r>
+              <a:rPr lang="en-US" dirty="0"/>
+              <a:t>[1] </a:t>
+            </a:r>
+            <a:r>
+              <a:rPr lang="en-US" dirty="0">
+                <a:hlinkClick r:id="rId2"/>
+              </a:rPr>
+              <a:t>https://www.plagiarism.org/article/what-is-citation</a:t>
+            </a:r>
+            <a:endParaRPr lang="en-US" dirty="0"/>
+          </a:p>
+          <a:p>
+            <a:r>
+              <a:rPr lang="en-US" dirty="0"/>
+              <a:t>[2] </a:t>
+            </a:r>
+            <a:r>
+              <a:rPr lang="en-US" dirty="0">
+                <a:hlinkClick r:id="rId3"/>
+              </a:rPr>
+              <a:t>https://www.usm.edu/speaking-center/citingsourcesinaspeech.pdf</a:t>
+            </a:r>
+            <a:endParaRPr lang="en-US" dirty="0"/>
+          </a:p>
+          <a:p>
+            <a:r>
+              <a:rPr lang="en-US" dirty="0"/>
+              <a:t>[3] </a:t>
+            </a:r>
+            <a:r>
+              <a:rPr lang="en-US" dirty="0">
+                <a:hlinkClick r:id="rId4"/>
+              </a:rPr>
+              <a:t>https://www.cbsnews.com/newyork/news/autism-spectrum-works-nonprofit-pop-up-stores-american-dream/</a:t>
+            </a:r>
+            <a:endParaRPr lang="en-US" dirty="0"/>
+          </a:p>
+          <a:p>
+            <a:r>
+              <a:rPr lang="en-US" dirty="0"/>
+              <a:t>[4] </a:t>
+            </a:r>
+            <a:r>
+              <a:rPr lang="en-US" dirty="0">
+                <a:hlinkClick r:id="rId5"/>
+              </a:rPr>
+              <a:t>https://lo.unisa.edu.au/mod/book/view.php?id=252144</a:t>
+            </a:r>
+            <a:endParaRPr lang="en-US" dirty="0"/>
+          </a:p>
+          <a:p>
+            <a:r>
+              <a:rPr lang="en-US" dirty="0"/>
+              <a:t>[5] </a:t>
+            </a:r>
+            <a:r>
+              <a:rPr lang="en-US" dirty="0">
+                <a:hlinkClick r:id="rId6"/>
+              </a:rPr>
+              <a:t>https://www.monash.edu/learnhq/write-like-a-pro/acknowledge-sources/paraphrase-summarise-and-quote-well/paraphrase</a:t>
+            </a:r>
+            <a:endParaRPr lang="en-US" dirty="0"/>
+          </a:p>
+          <a:p>
+            <a:r>
+              <a:rPr lang="en-US" dirty="0"/>
+              <a:t>[6] </a:t>
+            </a:r>
+            <a:r>
+              <a:rPr lang="en-US" dirty="0">
+                <a:hlinkClick r:id="rId7"/>
+              </a:rPr>
+              <a:t>https://apastyle.apa.org/style-grammar-guidelines/citations/quotations</a:t>
+            </a:r>
+            <a:endParaRPr lang="en-US" dirty="0"/>
+          </a:p>
+          <a:p>
+            <a:endParaRPr lang="en-US" dirty="0"/>
+          </a:p>
+          <a:p>
+            <a:endParaRPr lang="en-US" dirty="0"/>
+          </a:p>
+          <a:p>
+            <a:endParaRPr lang="en-US" dirty="0"/>
           </a:p>
         </p:txBody>
       </p:sp>
@@ -13136,9 +13194,11 @@
           <a:bodyPr/>
           <a:lstStyle/>
           <a:p>
-            <a:r>
-              <a:t>5/1/2023</a:t>
-            </a:r>
+            <a:fld id="{F5DADB09-3B6C-4031-97E6-2B2CAC5AD84D}" type="datetime1">
+              <a:rPr lang="en-US" smtClean="0"/>
+              <a:t>1/5/2023</a:t>
+            </a:fld>
+            <a:endParaRPr lang="en-US" dirty="0"/>
           </a:p>
         </p:txBody>
       </p:sp>
@@ -13162,7 +13222,9 @@
         <p:txBody>
           <a:bodyPr/>
           <a:lstStyle/>
-          <a:p/>
+          <a:p>
+            <a:endParaRPr lang="en-US" dirty="0"/>
+          </a:p>
         </p:txBody>
       </p:sp>
       <p:sp>
@@ -13186,9 +13248,11 @@
           <a:bodyPr/>
           <a:lstStyle/>
           <a:p>
-            <a:r>
+            <a:fld id="{D8DA9DAA-006C-4F4B-980E-E3DF019B24E2}" type="slidenum">
+              <a:rPr lang="en-US" smtClean="0"/>
               <a:t>10</a:t>
-            </a:r>
+            </a:fld>
+            <a:endParaRPr lang="en-US" dirty="0"/>
           </a:p>
         </p:txBody>
       </p:sp>
@@ -13244,7 +13308,8 @@
           <a:lstStyle/>
           <a:p>
             <a:r>
-              <a:t>¿Qué es citar [1]?</a:t>
+              <a:rPr lang="en-US" dirty="0"/>
+              <a:t>What is citing [1]?</a:t>
             </a:r>
           </a:p>
         </p:txBody>
@@ -13271,24 +13336,39 @@
           <a:lstStyle/>
           <a:p>
             <a:r>
-              <a:t>Citar informa a los lectores de dónde proviene su información.</a:t>
-            </a:r>
-          </a:p>
-          <a:p>
-            <a:r>
-              <a:t>Indicar que su información proviene de otra fuente.</a:t>
-            </a:r>
-          </a:p>
-          <a:p>
-            <a:r>
-              <a:t>Indicando de dónde proviene su información</a:t>
-            </a:r>
-          </a:p>
-          <a:p/>
-          <a:p>
-            <a:r>
-              <a:t>Las citas proporcionan evidencia para respaldar sus argumentos.</a:t>
-            </a:r>
+              <a:rPr lang="en-US" dirty="0"/>
+              <a:t>Citing informs readers where your information came from.</a:t>
+            </a:r>
+          </a:p>
+          <a:p>
+            <a:r>
+              <a:rPr lang="en-US" dirty="0"/>
+              <a:t>Stating your information is from another source</a:t>
+            </a:r>
+          </a:p>
+          <a:p>
+            <a:r>
+              <a:rPr lang="en-US" dirty="0"/>
+              <a:t>Stating where your information is from</a:t>
+            </a:r>
+          </a:p>
+          <a:p>
+            <a:endParaRPr lang="en-US" dirty="0"/>
+          </a:p>
+          <a:p>
+            <a:r>
+              <a:rPr lang="en-US" dirty="0"/>
+              <a:t>Citations provide evidence to support your arguments.</a:t>
+            </a:r>
+          </a:p>
+          <a:p>
+            <a:pPr marL="0" indent="0">
+              <a:buNone/>
+            </a:pPr>
+            <a:endParaRPr lang="en-US" dirty="0"/>
+          </a:p>
+          <a:p>
+            <a:endParaRPr lang="en-US" dirty="0"/>
           </a:p>
         </p:txBody>
       </p:sp>
@@ -13313,9 +13393,11 @@
           <a:bodyPr/>
           <a:lstStyle/>
           <a:p>
-            <a:r>
-              <a:t>5/1/2023</a:t>
-            </a:r>
+            <a:fld id="{93D639C6-2F89-4E91-911F-1DBD7DF426EE}" type="datetime1">
+              <a:rPr lang="en-US" smtClean="0"/>
+              <a:t>1/5/2023</a:t>
+            </a:fld>
+            <a:endParaRPr lang="en-US" dirty="0"/>
           </a:p>
         </p:txBody>
       </p:sp>
@@ -13339,7 +13421,9 @@
         <p:txBody>
           <a:bodyPr/>
           <a:lstStyle/>
-          <a:p/>
+          <a:p>
+            <a:endParaRPr lang="en-US" dirty="0"/>
+          </a:p>
         </p:txBody>
       </p:sp>
       <p:sp>
@@ -13363,9 +13447,11 @@
           <a:bodyPr/>
           <a:lstStyle/>
           <a:p>
-            <a:r>
+            <a:fld id="{D8DA9DAA-006C-4F4B-980E-E3DF019B24E2}" type="slidenum">
+              <a:rPr lang="en-US" smtClean="0"/>
               <a:t>2</a:t>
-            </a:r>
+            </a:fld>
+            <a:endParaRPr lang="en-US" dirty="0"/>
           </a:p>
         </p:txBody>
       </p:sp>
@@ -13421,7 +13507,8 @@
           <a:lstStyle/>
           <a:p>
             <a:r>
-              <a:t>Citar mientras se habla</a:t>
+              <a:rPr lang="en-US" dirty="0"/>
+              <a:t>Citing while speaking</a:t>
             </a:r>
           </a:p>
         </p:txBody>
@@ -13448,27 +13535,35 @@
           <a:lstStyle/>
           <a:p>
             <a:r>
-              <a:t>Decir cuando la información proviene de otro lugar [2].</a:t>
-            </a:r>
-          </a:p>
-          <a:p>
-            <a:r>
-              <a:t>¿Cómo hacerlo?</a:t>
-            </a:r>
-          </a:p>
-          <a:p>
-            <a:r>
-              <a:t>Según un artículo de Associated Press.</a:t>
-            </a:r>
-          </a:p>
-          <a:p>
-            <a:r>
-              <a:t>La Comisión de Vehículos Motorizados de Nueva Jersey exige que...</a:t>
-            </a:r>
-          </a:p>
-          <a:p>
-            <a:r>
-              <a:t>Durante una entrevista con CBS el 24 de agosto de 2021, Ann Marie Sullivan señaló [3]</a:t>
+              <a:rPr lang="en-US" dirty="0"/>
+              <a:t>Say when information is from elsewhere [2].</a:t>
+            </a:r>
+          </a:p>
+          <a:p>
+            <a:r>
+              <a:rPr lang="en-US" dirty="0"/>
+              <a:t>How to do so</a:t>
+            </a:r>
+          </a:p>
+          <a:p>
+            <a:pPr lvl="1"/>
+            <a:r>
+              <a:rPr lang="en-US" dirty="0"/>
+              <a:t>According to an article by the Associated Press.</a:t>
+            </a:r>
+          </a:p>
+          <a:p>
+            <a:pPr lvl="1"/>
+            <a:r>
+              <a:rPr lang="en-US" dirty="0"/>
+              <a:t>New Jersey’s Motor Vehicle Commission requires that…</a:t>
+            </a:r>
+          </a:p>
+          <a:p>
+            <a:pPr lvl="1"/>
+            <a:r>
+              <a:rPr lang="en-US" dirty="0"/>
+              <a:t>During an interview with CBS on August 24, 2021, Ann Marie Sullivan noted [3]</a:t>
             </a:r>
           </a:p>
         </p:txBody>
@@ -13494,9 +13589,11 @@
           <a:bodyPr/>
           <a:lstStyle/>
           <a:p>
-            <a:r>
-              <a:t>5/1/2023</a:t>
-            </a:r>
+            <a:fld id="{35F0998F-301C-4895-99C2-1BC2DC6D52A6}" type="datetime1">
+              <a:rPr lang="en-US" smtClean="0"/>
+              <a:t>1/5/2023</a:t>
+            </a:fld>
+            <a:endParaRPr lang="en-US" dirty="0"/>
           </a:p>
         </p:txBody>
       </p:sp>
@@ -13520,7 +13617,9 @@
         <p:txBody>
           <a:bodyPr/>
           <a:lstStyle/>
-          <a:p/>
+          <a:p>
+            <a:endParaRPr lang="en-US" dirty="0"/>
+          </a:p>
         </p:txBody>
       </p:sp>
       <p:sp>
@@ -13544,9 +13643,11 @@
           <a:bodyPr/>
           <a:lstStyle/>
           <a:p>
-            <a:r>
+            <a:fld id="{D8DA9DAA-006C-4F4B-980E-E3DF019B24E2}" type="slidenum">
+              <a:rPr lang="en-US" smtClean="0"/>
               <a:t>3</a:t>
-            </a:r>
+            </a:fld>
+            <a:endParaRPr lang="en-US" dirty="0"/>
           </a:p>
         </p:txBody>
       </p:sp>
@@ -13602,7 +13703,8 @@
           <a:lstStyle/>
           <a:p>
             <a:r>
-              <a:t>¿Qué es parafrasear?</a:t>
+              <a:rPr lang="en-US" dirty="0"/>
+              <a:t>What is paraphrasing?</a:t>
             </a:r>
           </a:p>
         </p:txBody>
@@ -13629,33 +13731,43 @@
           <a:lstStyle/>
           <a:p>
             <a:r>
-              <a:t>Reorganizar palabras conservando el significado [4].</a:t>
-            </a:r>
-          </a:p>
-          <a:p>
-            <a:r>
-              <a:t>Intente parafrasear más que citar directamente. </a:t>
-            </a:r>
-          </a:p>
-          <a:p>
-            <a:r>
-              <a:t>Parafrasear muestra mejor comprensión [4].</a:t>
-            </a:r>
-          </a:p>
-          <a:p/>
-          <a:p>
-            <a:r>
-              <a:t>Cuándo parafrasear:</a:t>
-            </a:r>
-          </a:p>
-          <a:p>
-            <a:r>
-              <a:t>La idea principal es más importante que las palabras exactas [5].</a:t>
-            </a:r>
-          </a:p>
-          <a:p>
-            <a:r>
-              <a:t>Sólo una pequeña parte de una fuente es útil[5].</a:t>
+              <a:rPr lang="en-US" dirty="0"/>
+              <a:t>Rearranging words while retaining meaning [4].</a:t>
+            </a:r>
+          </a:p>
+          <a:p>
+            <a:r>
+              <a:rPr lang="en-US" dirty="0"/>
+              <a:t>Try to paraphrase more than directly quoting. </a:t>
+            </a:r>
+          </a:p>
+          <a:p>
+            <a:r>
+              <a:rPr lang="en-US" dirty="0"/>
+              <a:t>Paraphrasing better displays understanding [4].</a:t>
+            </a:r>
+          </a:p>
+          <a:p>
+            <a:endParaRPr lang="en-US" dirty="0"/>
+          </a:p>
+          <a:p>
+            <a:r>
+              <a:rPr lang="en-US" dirty="0"/>
+              <a:t>When to Paraphrase:</a:t>
+            </a:r>
+          </a:p>
+          <a:p>
+            <a:pPr lvl="1"/>
+            <a:r>
+              <a:rPr lang="en-US" dirty="0"/>
+              <a:t>Main idea is more important than exact words [5].</a:t>
+            </a:r>
+          </a:p>
+          <a:p>
+            <a:pPr lvl="1"/>
+            <a:r>
+              <a:rPr lang="en-US" dirty="0"/>
+              <a:t>Only a small part of a source is useful.[5].</a:t>
             </a:r>
           </a:p>
         </p:txBody>
@@ -13681,9 +13793,11 @@
           <a:bodyPr/>
           <a:lstStyle/>
           <a:p>
-            <a:r>
-              <a:t>5/1/2023</a:t>
-            </a:r>
+            <a:fld id="{32EA8326-53E3-40E3-A5BD-DF3E18F2DF62}" type="datetime1">
+              <a:rPr lang="en-US" smtClean="0"/>
+              <a:t>1/5/2023</a:t>
+            </a:fld>
+            <a:endParaRPr lang="en-US" dirty="0"/>
           </a:p>
         </p:txBody>
       </p:sp>
@@ -13707,7 +13821,9 @@
         <p:txBody>
           <a:bodyPr/>
           <a:lstStyle/>
-          <a:p/>
+          <a:p>
+            <a:endParaRPr lang="en-US" dirty="0"/>
+          </a:p>
         </p:txBody>
       </p:sp>
       <p:sp>
@@ -13731,9 +13847,11 @@
           <a:bodyPr/>
           <a:lstStyle/>
           <a:p>
-            <a:r>
+            <a:fld id="{D8DA9DAA-006C-4F4B-980E-E3DF019B24E2}" type="slidenum">
+              <a:rPr lang="en-US" smtClean="0"/>
               <a:t>4</a:t>
-            </a:r>
+            </a:fld>
+            <a:endParaRPr lang="en-US" dirty="0"/>
           </a:p>
         </p:txBody>
       </p:sp>
@@ -13789,7 +13907,8 @@
           <a:lstStyle/>
           <a:p>
             <a:r>
-              <a:t>¿Cómo parafrasear? [4]</a:t>
+              <a:rPr lang="en-US" dirty="0"/>
+              <a:t>How to paraphrase? [4]</a:t>
             </a:r>
           </a:p>
         </p:txBody>
@@ -13817,39 +13936,71 @@
           </a:bodyPr>
           <a:lstStyle/>
           <a:p>
-            <a:r>
-              <a:t>Leer y comprender el original.</a:t>
-            </a:r>
-          </a:p>
-          <a:p>
-            <a:r>
-              <a:t>Determinar los puntos principales.</a:t>
-            </a:r>
-          </a:p>
-          <a:p>
-            <a:r>
-              <a:t>Reescribe el texto sin mirar el original.</a:t>
-            </a:r>
-          </a:p>
-          <a:p>
-            <a:r>
-              <a:t>Modifique el texto reescrito para que difiera del original.</a:t>
-            </a:r>
-          </a:p>
-          <a:p>
-            <a:r>
-              <a:t>Citar fuente de información.</a:t>
-            </a:r>
-          </a:p>
-          <a:p/>
-          <a:p>
-            <a:r>
-              <a:t>Tu escritura es lo suficientemente buena.</a:t>
-            </a:r>
-          </a:p>
-          <a:p>
-            <a:r>
-              <a:t>Parafrasear te ayuda a mejorar.</a:t>
+            <a:pPr marL="457200" indent="-457200">
+              <a:buFont typeface="+mj-lt"/>
+              <a:buAutoNum type="arabicPeriod"/>
+            </a:pPr>
+            <a:r>
+              <a:rPr lang="en-US" dirty="0"/>
+              <a:t>Read and understand original</a:t>
+            </a:r>
+          </a:p>
+          <a:p>
+            <a:pPr marL="457200" indent="-457200">
+              <a:buFont typeface="+mj-lt"/>
+              <a:buAutoNum type="arabicPeriod"/>
+            </a:pPr>
+            <a:r>
+              <a:rPr lang="en-US" dirty="0"/>
+              <a:t>Determine the main points.</a:t>
+            </a:r>
+          </a:p>
+          <a:p>
+            <a:pPr marL="457200" indent="-457200">
+              <a:buFont typeface="+mj-lt"/>
+              <a:buAutoNum type="arabicPeriod"/>
+            </a:pPr>
+            <a:r>
+              <a:rPr lang="en-US" dirty="0"/>
+              <a:t>Rewrite text without looking at original.</a:t>
+            </a:r>
+          </a:p>
+          <a:p>
+            <a:pPr marL="457200" indent="-457200">
+              <a:buFont typeface="+mj-lt"/>
+              <a:buAutoNum type="arabicPeriod"/>
+            </a:pPr>
+            <a:r>
+              <a:rPr lang="en-US" dirty="0"/>
+              <a:t>Modify rewritten text to differ from original.</a:t>
+            </a:r>
+          </a:p>
+          <a:p>
+            <a:pPr marL="457200" indent="-457200">
+              <a:buFont typeface="+mj-lt"/>
+              <a:buAutoNum type="arabicPeriod"/>
+            </a:pPr>
+            <a:r>
+              <a:rPr lang="en-US" dirty="0"/>
+              <a:t>Cite information source.</a:t>
+            </a:r>
+          </a:p>
+          <a:p>
+            <a:pPr marL="0" indent="0">
+              <a:buNone/>
+            </a:pPr>
+            <a:endParaRPr lang="en-US" dirty="0"/>
+          </a:p>
+          <a:p>
+            <a:r>
+              <a:rPr lang="en-US" dirty="0"/>
+              <a:t>Your writing is good enough.</a:t>
+            </a:r>
+          </a:p>
+          <a:p>
+            <a:r>
+              <a:rPr lang="en-US" dirty="0"/>
+              <a:t>Paraphrasing helps you improve.</a:t>
             </a:r>
           </a:p>
         </p:txBody>
@@ -13875,9 +14026,11 @@
           <a:bodyPr/>
           <a:lstStyle/>
           <a:p>
-            <a:r>
-              <a:t>5/1/2023</a:t>
-            </a:r>
+            <a:fld id="{7C9FC30B-008D-4643-B09E-87FB94064E23}" type="datetime1">
+              <a:rPr lang="en-US" smtClean="0"/>
+              <a:t>1/5/2023</a:t>
+            </a:fld>
+            <a:endParaRPr lang="en-US" dirty="0"/>
           </a:p>
         </p:txBody>
       </p:sp>
@@ -13901,7 +14054,9 @@
         <p:txBody>
           <a:bodyPr/>
           <a:lstStyle/>
-          <a:p/>
+          <a:p>
+            <a:endParaRPr lang="en-US" dirty="0"/>
+          </a:p>
         </p:txBody>
       </p:sp>
       <p:sp>
@@ -13925,9 +14080,11 @@
           <a:bodyPr/>
           <a:lstStyle/>
           <a:p>
-            <a:r>
+            <a:fld id="{D8DA9DAA-006C-4F4B-980E-E3DF019B24E2}" type="slidenum">
+              <a:rPr lang="en-US" smtClean="0"/>
               <a:t>5</a:t>
-            </a:r>
+            </a:fld>
+            <a:endParaRPr lang="en-US" dirty="0"/>
           </a:p>
         </p:txBody>
       </p:sp>
@@ -13983,7 +14140,8 @@
           <a:lstStyle/>
           <a:p>
             <a:r>
-              <a:t>¿Qué es una cotización directa?</a:t>
+              <a:rPr lang="en-US" dirty="0"/>
+              <a:t>What is a Direct Quote?</a:t>
             </a:r>
           </a:p>
         </p:txBody>
@@ -14010,19 +14168,28 @@
           <a:lstStyle/>
           <a:p>
             <a:r>
-              <a:t>Usando las palabras exactas del autor o sus palabras exactas [6].</a:t>
-            </a:r>
-          </a:p>
-          <a:p/>
-          <a:p>
-            <a:r>
-              <a:t>Ejemplo:</a:t>
-            </a:r>
-          </a:p>
-          <a:p>
-            <a:r>
-              <a:t>Ann Marie Sullivan dijo en una entrevista de agosto de 2021 con CBS que los adultos jóvenes con autismo reciben un apoyo insuficiente después de graduarse de los programas escolares [3]. Según ella, "lo que pasa es que cuando tienen 21 años y dejan los programas escolares realmente hay un bajón y no están teniendo esa oportunidad de trabajar dentro de empresas, empresas reales".</a:t>
-            </a:r>
+              <a:rPr lang="en-US" dirty="0"/>
+              <a:t>Using author’s exact words or your exact words [6].</a:t>
+            </a:r>
+          </a:p>
+          <a:p>
+            <a:endParaRPr lang="en-US" dirty="0"/>
+          </a:p>
+          <a:p>
+            <a:r>
+              <a:rPr lang="en-US" dirty="0"/>
+              <a:t>Example:</a:t>
+            </a:r>
+          </a:p>
+          <a:p>
+            <a:pPr algn="just"/>
+            <a:r>
+              <a:rPr lang="en-US" dirty="0"/>
+              <a:t>Ann Marie Sullivan said in an August 2021 interview with CBS that young adults with autism do receive insufficient support after graduating from school programs [3]. According to her, "What happens is that when they're 21 and they leave the school programs there is really a drop off and they're not having that opportunity to work inside of companies, real companies."</a:t>
+            </a:r>
+          </a:p>
+          <a:p>
+            <a:endParaRPr lang="en-US" dirty="0"/>
           </a:p>
         </p:txBody>
       </p:sp>
@@ -14047,9 +14214,11 @@
           <a:bodyPr/>
           <a:lstStyle/>
           <a:p>
-            <a:r>
-              <a:t>5/1/2023</a:t>
-            </a:r>
+            <a:fld id="{07910BF6-022D-40CF-B753-4C393C84CAAA}" type="datetime1">
+              <a:rPr lang="en-US" smtClean="0"/>
+              <a:t>1/5/2023</a:t>
+            </a:fld>
+            <a:endParaRPr lang="en-US" dirty="0"/>
           </a:p>
         </p:txBody>
       </p:sp>
@@ -14073,7 +14242,9 @@
         <p:txBody>
           <a:bodyPr/>
           <a:lstStyle/>
-          <a:p/>
+          <a:p>
+            <a:endParaRPr lang="en-US" dirty="0"/>
+          </a:p>
         </p:txBody>
       </p:sp>
       <p:sp>
@@ -14097,9 +14268,11 @@
           <a:bodyPr/>
           <a:lstStyle/>
           <a:p>
-            <a:r>
+            <a:fld id="{D8DA9DAA-006C-4F4B-980E-E3DF019B24E2}" type="slidenum">
+              <a:rPr lang="en-US" smtClean="0"/>
               <a:t>6</a:t>
-            </a:r>
+            </a:fld>
+            <a:endParaRPr lang="en-US" dirty="0"/>
           </a:p>
         </p:txBody>
       </p:sp>
@@ -14155,7 +14328,8 @@
           <a:lstStyle/>
           <a:p>
             <a:r>
-              <a:t>Cuándo citar directamente [6]</a:t>
+              <a:rPr lang="en-US" dirty="0"/>
+              <a:t>When to directly quote [6]</a:t>
             </a:r>
           </a:p>
         </p:txBody>
@@ -14182,34 +14356,49 @@
           <a:lstStyle/>
           <a:p>
             <a:r>
-              <a:t>Se prefiere parafrasear.</a:t>
-            </a:r>
-          </a:p>
-          <a:p/>
-          <a:p>
-            <a:r>
-              <a:t>Sin embargo, las citas siguen siendo útiles.</a:t>
-            </a:r>
-          </a:p>
-          <a:p>
-            <a:r>
-              <a:t>Casos para usar comillas directas:</a:t>
-            </a:r>
-          </a:p>
-          <a:p>
-            <a:r>
-              <a:t>Definición específica</a:t>
-            </a:r>
-          </a:p>
-          <a:p>
-            <a:r>
-              <a:t>Puntos particularmente bien expresados.</a:t>
-            </a:r>
-          </a:p>
-          <a:p>
-            <a:r>
-              <a:t>Escribir sobre la declaración exacta</a:t>
-            </a:r>
+              <a:rPr lang="en-US" dirty="0"/>
+              <a:t>Paraphrasing is preferred.</a:t>
+            </a:r>
+          </a:p>
+          <a:p>
+            <a:endParaRPr lang="en-US" dirty="0"/>
+          </a:p>
+          <a:p>
+            <a:r>
+              <a:rPr lang="en-US" dirty="0"/>
+              <a:t>Quotes are still useful though.</a:t>
+            </a:r>
+          </a:p>
+          <a:p>
+            <a:r>
+              <a:rPr lang="en-US" dirty="0"/>
+              <a:t>Cases for using direct quotes:</a:t>
+            </a:r>
+          </a:p>
+          <a:p>
+            <a:pPr lvl="1"/>
+            <a:r>
+              <a:rPr lang="en-US" dirty="0"/>
+              <a:t>Specific definition</a:t>
+            </a:r>
+          </a:p>
+          <a:p>
+            <a:pPr lvl="1"/>
+            <a:r>
+              <a:rPr lang="en-US" dirty="0"/>
+              <a:t>Particularly well stated points.</a:t>
+            </a:r>
+          </a:p>
+          <a:p>
+            <a:pPr lvl="1"/>
+            <a:r>
+              <a:rPr lang="en-US" dirty="0"/>
+              <a:t>Writing about exact statement</a:t>
+            </a:r>
+          </a:p>
+          <a:p>
+            <a:pPr lvl="1"/>
+            <a:endParaRPr lang="en-US" dirty="0"/>
           </a:p>
         </p:txBody>
       </p:sp>
@@ -14234,9 +14423,11 @@
           <a:bodyPr/>
           <a:lstStyle/>
           <a:p>
-            <a:r>
-              <a:t>5/1/2023</a:t>
-            </a:r>
+            <a:fld id="{25DB5319-33C3-4309-B5DB-7E7C7D85D509}" type="datetime1">
+              <a:rPr lang="en-US" smtClean="0"/>
+              <a:t>1/5/2023</a:t>
+            </a:fld>
+            <a:endParaRPr lang="en-US" dirty="0"/>
           </a:p>
         </p:txBody>
       </p:sp>
@@ -14260,7 +14451,9 @@
         <p:txBody>
           <a:bodyPr/>
           <a:lstStyle/>
-          <a:p/>
+          <a:p>
+            <a:endParaRPr lang="en-US" dirty="0"/>
+          </a:p>
         </p:txBody>
       </p:sp>
       <p:sp>
@@ -14284,9 +14477,11 @@
           <a:bodyPr/>
           <a:lstStyle/>
           <a:p>
-            <a:r>
+            <a:fld id="{D8DA9DAA-006C-4F4B-980E-E3DF019B24E2}" type="slidenum">
+              <a:rPr lang="en-US" smtClean="0"/>
               <a:t>7</a:t>
-            </a:r>
+            </a:fld>
+            <a:endParaRPr lang="en-US" dirty="0"/>
           </a:p>
         </p:txBody>
       </p:sp>
@@ -14342,8 +14537,18 @@
           <a:lstStyle/>
           <a:p>
             <a:r>
-              <a:t>Consejos de Scribbr sobre parafraseo</a:t>
-            </a:r>
+              <a:rPr lang="en-US" dirty="0" err="1"/>
+              <a:t>Scribbr</a:t>
+            </a:r>
+            <a:r>
+              <a:rPr lang="en-US" dirty="0"/>
+              <a:t> Advise </a:t>
+            </a:r>
+            <a:r>
+              <a:rPr lang="en-US"/>
+              <a:t>on Paraphrasing</a:t>
+            </a:r>
+            <a:endParaRPr lang="en-US" dirty="0"/>
           </a:p>
         </p:txBody>
       </p:sp>
@@ -14402,9 +14607,11 @@
           <a:bodyPr/>
           <a:lstStyle/>
           <a:p>
-            <a:r>
-              <a:t>5/1/2023</a:t>
-            </a:r>
+            <a:fld id="{C0FC39E0-B17E-4827-BE4A-EE15A469FEC9}" type="datetime1">
+              <a:rPr lang="en-US" smtClean="0"/>
+              <a:t>1/5/2023</a:t>
+            </a:fld>
+            <a:endParaRPr lang="en-US" dirty="0"/>
           </a:p>
         </p:txBody>
       </p:sp>
@@ -14428,7 +14635,9 @@
         <p:txBody>
           <a:bodyPr/>
           <a:lstStyle/>
-          <a:p/>
+          <a:p>
+            <a:endParaRPr lang="en-US" dirty="0"/>
+          </a:p>
         </p:txBody>
       </p:sp>
       <p:sp>
@@ -14452,9 +14661,11 @@
           <a:bodyPr/>
           <a:lstStyle/>
           <a:p>
-            <a:r>
+            <a:fld id="{D8DA9DAA-006C-4F4B-980E-E3DF019B24E2}" type="slidenum">
+              <a:rPr lang="en-US" smtClean="0"/>
               <a:t>8</a:t>
-            </a:r>
+            </a:fld>
+            <a:endParaRPr lang="en-US" dirty="0"/>
           </a:p>
         </p:txBody>
       </p:sp>
@@ -14645,7 +14856,8 @@
           <a:lstStyle/>
           <a:p>
             <a:r>
-              <a:t>Conclusión</a:t>
+              <a:rPr lang="en-US" dirty="0"/>
+              <a:t>Conclusion</a:t>
             </a:r>
           </a:p>
         </p:txBody>
@@ -14672,17 +14884,20 @@
           <a:lstStyle/>
           <a:p>
             <a:r>
-              <a:t>Cita siempre los recursos.</a:t>
-            </a:r>
-          </a:p>
-          <a:p>
-            <a:r>
-              <a:t>Generalmente, parafrasee las palabras e ideas de otras personas.</a:t>
-            </a:r>
-          </a:p>
-          <a:p>
-            <a:r>
-              <a:t>Utilice citas directas mínimamente.</a:t>
+              <a:rPr lang="en-US" dirty="0"/>
+              <a:t>Always cite resources.</a:t>
+            </a:r>
+          </a:p>
+          <a:p>
+            <a:r>
+              <a:rPr lang="en-US" dirty="0"/>
+              <a:t>Generally, paraphrase other people’s words and ideas.</a:t>
+            </a:r>
+          </a:p>
+          <a:p>
+            <a:r>
+              <a:rPr lang="en-US" dirty="0"/>
+              <a:t>Use direct quotations minimally.</a:t>
             </a:r>
           </a:p>
         </p:txBody>
@@ -14708,9 +14923,11 @@
           <a:bodyPr/>
           <a:lstStyle/>
           <a:p>
-            <a:r>
-              <a:t>5/1/2023</a:t>
-            </a:r>
+            <a:fld id="{5B3B3F56-EE44-4955-9EAF-7EE59F9F0990}" type="datetime1">
+              <a:rPr lang="en-US" smtClean="0"/>
+              <a:t>1/5/2023</a:t>
+            </a:fld>
+            <a:endParaRPr lang="en-US" dirty="0"/>
           </a:p>
         </p:txBody>
       </p:sp>
@@ -14734,7 +14951,9 @@
         <p:txBody>
           <a:bodyPr/>
           <a:lstStyle/>
-          <a:p/>
+          <a:p>
+            <a:endParaRPr lang="en-US" dirty="0"/>
+          </a:p>
         </p:txBody>
       </p:sp>
       <p:sp>
@@ -14758,9 +14977,11 @@
           <a:bodyPr/>
           <a:lstStyle/>
           <a:p>
-            <a:r>
+            <a:fld id="{D8DA9DAA-006C-4F4B-980E-E3DF019B24E2}" type="slidenum">
+              <a:rPr lang="en-US" smtClean="0"/>
               <a:t>9</a:t>
-            </a:r>
+            </a:fld>
+            <a:endParaRPr lang="en-US" dirty="0"/>
           </a:p>
         </p:txBody>
       </p:sp>

</xml_diff>